<commit_message>
Agresion al arbitro: expulsion inmediata e inapelable
</commit_message>
<xml_diff>
--- a/Reunion-Delegados-Junior-LIV-2026.pptx
+++ b/Reunion-Delegados-Junior-LIV-2026.pptx
@@ -12175,7 +12175,7 @@
       </p:sp>
       <p:pic>
         <p:nvPicPr>
-          <p:cNvPr id="5" name="Image 0" descr="/root/.claude/skills/synced/liv-presentation/assets/fotos/complejo-cancha.jpg">    </p:cNvPr>
+          <p:cNvPr id="5" name="Image 0" descr="/home/claude/LIV/deck-assets/canchas-aerea.jpg">    </p:cNvPr>
           <p:cNvPicPr>
             <a:picLocks noChangeAspect="1"/>
           </p:cNvPicPr>
@@ -12767,7 +12767,7 @@
       </p:grpSpPr>
       <p:pic>
         <p:nvPicPr>
-          <p:cNvPr id="2" name="Image 0" descr="/root/.claude/skills/synced/liv-presentation/assets/fotos/duo-accion.jpg">    </p:cNvPr>
+          <p:cNvPr id="2" name="Image 0" descr="/home/claude/LIV/deck-assets/fixture-web-framed.png">    </p:cNvPr>
           <p:cNvPicPr>
             <a:picLocks noChangeAspect="1"/>
           </p:cNvPicPr>

</xml_diff>